<commit_message>
Alterado fundo BI Produtos
Alterado ordenação dos visuais na aba de produtos para que fique com o visual em Z-pattern de forma mais lógica.
</commit_message>
<xml_diff>
--- a/Arquivos BI/Background - Fundo Para BI.pptx
+++ b/Arquivos BI/Background - Fundo Para BI.pptx
@@ -6,15 +6,16 @@
   </p:sldMasterIdLst>
   <p:sldIdLst>
     <p:sldId id="431" r:id="rId5"/>
-    <p:sldId id="434" r:id="rId6"/>
-    <p:sldId id="435" r:id="rId7"/>
-    <p:sldId id="379" r:id="rId8"/>
-    <p:sldId id="432" r:id="rId9"/>
-    <p:sldId id="433" r:id="rId10"/>
-    <p:sldId id="436" r:id="rId11"/>
-    <p:sldId id="437" r:id="rId12"/>
-    <p:sldId id="438" r:id="rId13"/>
-    <p:sldId id="439" r:id="rId14"/>
+    <p:sldId id="440" r:id="rId6"/>
+    <p:sldId id="434" r:id="rId7"/>
+    <p:sldId id="435" r:id="rId8"/>
+    <p:sldId id="379" r:id="rId9"/>
+    <p:sldId id="432" r:id="rId10"/>
+    <p:sldId id="433" r:id="rId11"/>
+    <p:sldId id="436" r:id="rId12"/>
+    <p:sldId id="437" r:id="rId13"/>
+    <p:sldId id="438" r:id="rId14"/>
+    <p:sldId id="439" r:id="rId15"/>
   </p:sldIdLst>
   <p:sldSz cx="51200050" cy="28800425"/>
   <p:notesSz cx="6858000" cy="9144000"/>
@@ -252,7 +253,7 @@
           <a:p>
             <a:fld id="{CF62B505-841C-4C89-B392-8F545B9B6E7F}" type="datetimeFigureOut">
               <a:rPr lang="pt-BR" smtClean="0"/>
-              <a:t>20/04/2026</a:t>
+              <a:t>21/04/2026</a:t>
             </a:fld>
             <a:endParaRPr lang="pt-BR"/>
           </a:p>
@@ -422,7 +423,7 @@
           <a:p>
             <a:fld id="{CF62B505-841C-4C89-B392-8F545B9B6E7F}" type="datetimeFigureOut">
               <a:rPr lang="pt-BR" smtClean="0"/>
-              <a:t>20/04/2026</a:t>
+              <a:t>21/04/2026</a:t>
             </a:fld>
             <a:endParaRPr lang="pt-BR"/>
           </a:p>
@@ -602,7 +603,7 @@
           <a:p>
             <a:fld id="{CF62B505-841C-4C89-B392-8F545B9B6E7F}" type="datetimeFigureOut">
               <a:rPr lang="pt-BR" smtClean="0"/>
-              <a:t>20/04/2026</a:t>
+              <a:t>21/04/2026</a:t>
             </a:fld>
             <a:endParaRPr lang="pt-BR"/>
           </a:p>
@@ -772,7 +773,7 @@
           <a:p>
             <a:fld id="{CF62B505-841C-4C89-B392-8F545B9B6E7F}" type="datetimeFigureOut">
               <a:rPr lang="pt-BR" smtClean="0"/>
-              <a:t>20/04/2026</a:t>
+              <a:t>21/04/2026</a:t>
             </a:fld>
             <a:endParaRPr lang="pt-BR"/>
           </a:p>
@@ -1018,7 +1019,7 @@
           <a:p>
             <a:fld id="{CF62B505-841C-4C89-B392-8F545B9B6E7F}" type="datetimeFigureOut">
               <a:rPr lang="pt-BR" smtClean="0"/>
-              <a:t>20/04/2026</a:t>
+              <a:t>21/04/2026</a:t>
             </a:fld>
             <a:endParaRPr lang="pt-BR"/>
           </a:p>
@@ -1250,7 +1251,7 @@
           <a:p>
             <a:fld id="{CF62B505-841C-4C89-B392-8F545B9B6E7F}" type="datetimeFigureOut">
               <a:rPr lang="pt-BR" smtClean="0"/>
-              <a:t>20/04/2026</a:t>
+              <a:t>21/04/2026</a:t>
             </a:fld>
             <a:endParaRPr lang="pt-BR"/>
           </a:p>
@@ -1617,7 +1618,7 @@
           <a:p>
             <a:fld id="{CF62B505-841C-4C89-B392-8F545B9B6E7F}" type="datetimeFigureOut">
               <a:rPr lang="pt-BR" smtClean="0"/>
-              <a:t>20/04/2026</a:t>
+              <a:t>21/04/2026</a:t>
             </a:fld>
             <a:endParaRPr lang="pt-BR"/>
           </a:p>
@@ -1735,7 +1736,7 @@
           <a:p>
             <a:fld id="{CF62B505-841C-4C89-B392-8F545B9B6E7F}" type="datetimeFigureOut">
               <a:rPr lang="pt-BR" smtClean="0"/>
-              <a:t>20/04/2026</a:t>
+              <a:t>21/04/2026</a:t>
             </a:fld>
             <a:endParaRPr lang="pt-BR"/>
           </a:p>
@@ -1830,7 +1831,7 @@
           <a:p>
             <a:fld id="{CF62B505-841C-4C89-B392-8F545B9B6E7F}" type="datetimeFigureOut">
               <a:rPr lang="pt-BR" smtClean="0"/>
-              <a:t>20/04/2026</a:t>
+              <a:t>21/04/2026</a:t>
             </a:fld>
             <a:endParaRPr lang="pt-BR"/>
           </a:p>
@@ -2107,7 +2108,7 @@
           <a:p>
             <a:fld id="{CF62B505-841C-4C89-B392-8F545B9B6E7F}" type="datetimeFigureOut">
               <a:rPr lang="pt-BR" smtClean="0"/>
-              <a:t>20/04/2026</a:t>
+              <a:t>21/04/2026</a:t>
             </a:fld>
             <a:endParaRPr lang="pt-BR"/>
           </a:p>
@@ -2364,7 +2365,7 @@
           <a:p>
             <a:fld id="{CF62B505-841C-4C89-B392-8F545B9B6E7F}" type="datetimeFigureOut">
               <a:rPr lang="pt-BR" smtClean="0"/>
-              <a:t>20/04/2026</a:t>
+              <a:t>21/04/2026</a:t>
             </a:fld>
             <a:endParaRPr lang="pt-BR"/>
           </a:p>
@@ -2577,7 +2578,7 @@
           <a:p>
             <a:fld id="{CF62B505-841C-4C89-B392-8F545B9B6E7F}" type="datetimeFigureOut">
               <a:rPr lang="pt-BR" smtClean="0"/>
-              <a:t>20/04/2026</a:t>
+              <a:t>21/04/2026</a:t>
             </a:fld>
             <a:endParaRPr lang="pt-BR"/>
           </a:p>
@@ -4037,6 +4038,197 @@
         <p:cNvPr id="1" name="">
           <a:extLst>
             <a:ext uri="{FF2B5EF4-FFF2-40B4-BE49-F238E27FC236}">
+              <a16:creationId xmlns:a16="http://schemas.microsoft.com/office/drawing/2014/main" id="{36DD52CC-89D5-2710-7D87-2A2E2CFF65E6}"/>
+            </a:ext>
+          </a:extLst>
+        </p:cNvPr>
+        <p:cNvGrpSpPr/>
+        <p:nvPr/>
+      </p:nvGrpSpPr>
+      <p:grpSpPr>
+        <a:xfrm>
+          <a:off x="0" y="0"/>
+          <a:ext cx="0" cy="0"/>
+          <a:chOff x="0" y="0"/>
+          <a:chExt cx="0" cy="0"/>
+        </a:xfrm>
+      </p:grpSpPr>
+      <p:sp>
+        <p:nvSpPr>
+          <p:cNvPr id="7" name="Retângulo: Cantos Arredondados 6">
+            <a:extLst>
+              <a:ext uri="{FF2B5EF4-FFF2-40B4-BE49-F238E27FC236}">
+                <a16:creationId xmlns:a16="http://schemas.microsoft.com/office/drawing/2014/main" id="{CC759720-71A5-1FCB-8BB1-A173F10EDD06}"/>
+              </a:ext>
+            </a:extLst>
+          </p:cNvPr>
+          <p:cNvSpPr/>
+          <p:nvPr/>
+        </p:nvSpPr>
+        <p:spPr>
+          <a:xfrm>
+            <a:off x="17697870" y="11242142"/>
+            <a:ext cx="13889388" cy="7611537"/>
+          </a:xfrm>
+          <a:prstGeom prst="roundRect">
+            <a:avLst>
+              <a:gd name="adj" fmla="val 3334"/>
+            </a:avLst>
+          </a:prstGeom>
+          <a:gradFill flip="none" rotWithShape="1">
+            <a:gsLst>
+              <a:gs pos="0">
+                <a:srgbClr val="05324B"/>
+              </a:gs>
+              <a:gs pos="62000">
+                <a:srgbClr val="032030"/>
+              </a:gs>
+              <a:gs pos="76000">
+                <a:srgbClr val="032030"/>
+              </a:gs>
+              <a:gs pos="100000">
+                <a:srgbClr val="032030"/>
+              </a:gs>
+            </a:gsLst>
+            <a:path path="circle">
+              <a:fillToRect l="50000" t="50000" r="50000" b="50000"/>
+            </a:path>
+            <a:tileRect/>
+          </a:gradFill>
+          <a:ln>
+            <a:noFill/>
+          </a:ln>
+        </p:spPr>
+        <p:style>
+          <a:lnRef idx="2">
+            <a:schemeClr val="accent1">
+              <a:shade val="50000"/>
+            </a:schemeClr>
+          </a:lnRef>
+          <a:fillRef idx="1">
+            <a:schemeClr val="accent1"/>
+          </a:fillRef>
+          <a:effectRef idx="0">
+            <a:schemeClr val="accent1"/>
+          </a:effectRef>
+          <a:fontRef idx="minor">
+            <a:schemeClr val="lt1"/>
+          </a:fontRef>
+        </p:style>
+        <p:txBody>
+          <a:bodyPr rtlCol="0" anchor="ctr"/>
+          <a:lstStyle/>
+          <a:p>
+            <a:pPr algn="ctr"/>
+            <a:endParaRPr lang="pt-BR" sz="2400"/>
+          </a:p>
+        </p:txBody>
+      </p:sp>
+      <p:sp>
+        <p:nvSpPr>
+          <p:cNvPr id="11" name="Retângulo: Cantos Arredondados 10">
+            <a:extLst>
+              <a:ext uri="{FF2B5EF4-FFF2-40B4-BE49-F238E27FC236}">
+                <a16:creationId xmlns:a16="http://schemas.microsoft.com/office/drawing/2014/main" id="{7FD3E36B-204D-5D77-C84C-6FCBBB86874D}"/>
+              </a:ext>
+            </a:extLst>
+          </p:cNvPr>
+          <p:cNvSpPr/>
+          <p:nvPr/>
+        </p:nvSpPr>
+        <p:spPr>
+          <a:xfrm>
+            <a:off x="18084800" y="11635685"/>
+            <a:ext cx="13068300" cy="1213647"/>
+          </a:xfrm>
+          <a:prstGeom prst="roundRect">
+            <a:avLst>
+              <a:gd name="adj" fmla="val 12781"/>
+            </a:avLst>
+          </a:prstGeom>
+          <a:gradFill flip="none" rotWithShape="1">
+            <a:gsLst>
+              <a:gs pos="0">
+                <a:srgbClr val="365160"/>
+              </a:gs>
+              <a:gs pos="62000">
+                <a:srgbClr val="032030"/>
+              </a:gs>
+              <a:gs pos="76000">
+                <a:srgbClr val="032030"/>
+              </a:gs>
+              <a:gs pos="100000">
+                <a:srgbClr val="032030"/>
+              </a:gs>
+            </a:gsLst>
+            <a:lin ang="2700000" scaled="1"/>
+            <a:tileRect/>
+          </a:gradFill>
+          <a:ln>
+            <a:noFill/>
+          </a:ln>
+          <a:effectLst>
+            <a:outerShdw blurRad="50800" dist="38100" dir="3300000" algn="t" rotWithShape="0">
+              <a:schemeClr val="bg1">
+                <a:alpha val="40000"/>
+              </a:schemeClr>
+            </a:outerShdw>
+          </a:effectLst>
+        </p:spPr>
+        <p:style>
+          <a:lnRef idx="2">
+            <a:schemeClr val="accent1">
+              <a:shade val="50000"/>
+            </a:schemeClr>
+          </a:lnRef>
+          <a:fillRef idx="1">
+            <a:schemeClr val="accent1"/>
+          </a:fillRef>
+          <a:effectRef idx="0">
+            <a:schemeClr val="accent1"/>
+          </a:effectRef>
+          <a:fontRef idx="minor">
+            <a:schemeClr val="lt1"/>
+          </a:fontRef>
+        </p:style>
+        <p:txBody>
+          <a:bodyPr rtlCol="0" anchor="ctr"/>
+          <a:lstStyle/>
+          <a:p>
+            <a:pPr algn="ctr"/>
+            <a:r>
+              <a:rPr lang="pt-BR" sz="4400" b="1" dirty="0">
+                <a:solidFill>
+                  <a:schemeClr val="bg1"/>
+                </a:solidFill>
+                <a:latin typeface="Din"/>
+              </a:rPr>
+              <a:t>Unidades Vendidas por Mês</a:t>
+            </a:r>
+          </a:p>
+        </p:txBody>
+      </p:sp>
+    </p:spTree>
+    <p:extLst>
+      <p:ext uri="{BB962C8B-B14F-4D97-AF65-F5344CB8AC3E}">
+        <p14:creationId xmlns:p14="http://schemas.microsoft.com/office/powerpoint/2010/main" val="3329092916"/>
+      </p:ext>
+    </p:extLst>
+  </p:cSld>
+  <p:clrMapOvr>
+    <a:masterClrMapping/>
+  </p:clrMapOvr>
+</p:sld>
+</file>
+
+<file path=ppt/slides/slide11.xml><?xml version="1.0" encoding="utf-8"?>
+<p:sld xmlns:a="http://schemas.openxmlformats.org/drawingml/2006/main" xmlns:r="http://schemas.openxmlformats.org/officeDocument/2006/relationships" xmlns:p="http://schemas.openxmlformats.org/presentationml/2006/main">
+  <p:cSld>
+    <p:spTree>
+      <p:nvGrpSpPr>
+        <p:cNvPr id="1" name="">
+          <a:extLst>
+            <a:ext uri="{FF2B5EF4-FFF2-40B4-BE49-F238E27FC236}">
               <a16:creationId xmlns:a16="http://schemas.microsoft.com/office/drawing/2014/main" id="{202BF169-882E-C49F-07C7-B586FB774366}"/>
             </a:ext>
           </a:extLst>
@@ -4257,6 +4449,1023 @@
 </file>
 
 <file path=ppt/slides/slide2.xml><?xml version="1.0" encoding="utf-8"?>
+<p:sld xmlns:a="http://schemas.openxmlformats.org/drawingml/2006/main" xmlns:r="http://schemas.openxmlformats.org/officeDocument/2006/relationships" xmlns:p="http://schemas.openxmlformats.org/presentationml/2006/main">
+  <p:cSld>
+    <p:spTree>
+      <p:nvGrpSpPr>
+        <p:cNvPr id="1" name="">
+          <a:extLst>
+            <a:ext uri="{FF2B5EF4-FFF2-40B4-BE49-F238E27FC236}">
+              <a16:creationId xmlns:a16="http://schemas.microsoft.com/office/drawing/2014/main" id="{CE9A7BF9-83B2-852A-A161-C0CD462C8525}"/>
+            </a:ext>
+          </a:extLst>
+        </p:cNvPr>
+        <p:cNvGrpSpPr/>
+        <p:nvPr/>
+      </p:nvGrpSpPr>
+      <p:grpSpPr>
+        <a:xfrm>
+          <a:off x="0" y="0"/>
+          <a:ext cx="0" cy="0"/>
+          <a:chOff x="0" y="0"/>
+          <a:chExt cx="0" cy="0"/>
+        </a:xfrm>
+      </p:grpSpPr>
+      <p:sp>
+        <p:nvSpPr>
+          <p:cNvPr id="37" name="Retângulo: Cantos Arredondados 36">
+            <a:extLst>
+              <a:ext uri="{FF2B5EF4-FFF2-40B4-BE49-F238E27FC236}">
+                <a16:creationId xmlns:a16="http://schemas.microsoft.com/office/drawing/2014/main" id="{D762C590-A456-EFBF-6045-4D09FBB9AA19}"/>
+              </a:ext>
+            </a:extLst>
+          </p:cNvPr>
+          <p:cNvSpPr/>
+          <p:nvPr/>
+        </p:nvSpPr>
+        <p:spPr>
+          <a:xfrm>
+            <a:off x="17472027" y="9852690"/>
+            <a:ext cx="16255996" cy="9119542"/>
+          </a:xfrm>
+          <a:prstGeom prst="roundRect">
+            <a:avLst>
+              <a:gd name="adj" fmla="val 3334"/>
+            </a:avLst>
+          </a:prstGeom>
+          <a:solidFill>
+            <a:srgbClr val="F5F7F9"/>
+          </a:solidFill>
+          <a:ln>
+            <a:solidFill>
+              <a:srgbClr val="F5F7F9"/>
+            </a:solidFill>
+          </a:ln>
+        </p:spPr>
+        <p:style>
+          <a:lnRef idx="2">
+            <a:schemeClr val="accent1">
+              <a:shade val="50000"/>
+            </a:schemeClr>
+          </a:lnRef>
+          <a:fillRef idx="1">
+            <a:schemeClr val="accent1"/>
+          </a:fillRef>
+          <a:effectRef idx="0">
+            <a:schemeClr val="accent1"/>
+          </a:effectRef>
+          <a:fontRef idx="minor">
+            <a:schemeClr val="lt1"/>
+          </a:fontRef>
+        </p:style>
+        <p:txBody>
+          <a:bodyPr rtlCol="0" anchor="ctr"/>
+          <a:lstStyle/>
+          <a:p>
+            <a:pPr algn="ctr"/>
+            <a:endParaRPr lang="pt-BR" sz="2400" dirty="0">
+              <a:solidFill>
+                <a:prstClr val="white"/>
+              </a:solidFill>
+              <a:latin typeface="Calibri" panose="020F0502020204030204"/>
+            </a:endParaRPr>
+          </a:p>
+        </p:txBody>
+      </p:sp>
+      <p:sp>
+        <p:nvSpPr>
+          <p:cNvPr id="25" name="Retângulo: Cantos Arredondados 24">
+            <a:extLst>
+              <a:ext uri="{FF2B5EF4-FFF2-40B4-BE49-F238E27FC236}">
+                <a16:creationId xmlns:a16="http://schemas.microsoft.com/office/drawing/2014/main" id="{D1169F5E-867B-0A28-68AC-7DB157D376BF}"/>
+              </a:ext>
+            </a:extLst>
+          </p:cNvPr>
+          <p:cNvSpPr/>
+          <p:nvPr/>
+        </p:nvSpPr>
+        <p:spPr>
+          <a:xfrm>
+            <a:off x="17587321" y="9925420"/>
+            <a:ext cx="995739" cy="9046812"/>
+          </a:xfrm>
+          <a:prstGeom prst="roundRect">
+            <a:avLst>
+              <a:gd name="adj" fmla="val 24349"/>
+            </a:avLst>
+          </a:prstGeom>
+          <a:gradFill flip="none" rotWithShape="1">
+            <a:gsLst>
+              <a:gs pos="0">
+                <a:srgbClr val="05324B"/>
+              </a:gs>
+              <a:gs pos="62000">
+                <a:srgbClr val="032030"/>
+              </a:gs>
+              <a:gs pos="76000">
+                <a:srgbClr val="032030"/>
+              </a:gs>
+              <a:gs pos="100000">
+                <a:srgbClr val="032030"/>
+              </a:gs>
+            </a:gsLst>
+            <a:lin ang="2700000" scaled="1"/>
+            <a:tileRect/>
+          </a:gradFill>
+          <a:ln>
+            <a:solidFill>
+              <a:srgbClr val="074365"/>
+            </a:solidFill>
+          </a:ln>
+          <a:effectLst>
+            <a:outerShdw blurRad="50800" dist="38100" dir="3300000" algn="t" rotWithShape="0">
+              <a:schemeClr val="bg1">
+                <a:alpha val="40000"/>
+              </a:schemeClr>
+            </a:outerShdw>
+          </a:effectLst>
+        </p:spPr>
+        <p:style>
+          <a:lnRef idx="2">
+            <a:schemeClr val="accent1">
+              <a:shade val="50000"/>
+            </a:schemeClr>
+          </a:lnRef>
+          <a:fillRef idx="1">
+            <a:schemeClr val="accent1"/>
+          </a:fillRef>
+          <a:effectRef idx="0">
+            <a:schemeClr val="accent1"/>
+          </a:effectRef>
+          <a:fontRef idx="minor">
+            <a:schemeClr val="lt1"/>
+          </a:fontRef>
+        </p:style>
+        <p:txBody>
+          <a:bodyPr vert="vert" rtlCol="0" anchor="ctr"/>
+          <a:lstStyle/>
+          <a:p>
+            <a:pPr algn="ctr"/>
+            <a:endParaRPr lang="pt-BR" sz="3467" dirty="0">
+              <a:solidFill>
+                <a:schemeClr val="bg1"/>
+              </a:solidFill>
+              <a:latin typeface="Din"/>
+            </a:endParaRPr>
+          </a:p>
+        </p:txBody>
+      </p:sp>
+      <p:grpSp>
+        <p:nvGrpSpPr>
+          <p:cNvPr id="23" name="Agrupar 22">
+            <a:extLst>
+              <a:ext uri="{FF2B5EF4-FFF2-40B4-BE49-F238E27FC236}">
+                <a16:creationId xmlns:a16="http://schemas.microsoft.com/office/drawing/2014/main" id="{DBD0783E-CEDB-EFFC-510E-96F00A1F10BC}"/>
+              </a:ext>
+            </a:extLst>
+          </p:cNvPr>
+          <p:cNvGrpSpPr/>
+          <p:nvPr/>
+        </p:nvGrpSpPr>
+        <p:grpSpPr>
+          <a:xfrm>
+            <a:off x="18698354" y="9925420"/>
+            <a:ext cx="14918545" cy="995739"/>
+            <a:chOff x="18680926" y="9879347"/>
+            <a:chExt cx="14002071" cy="1122481"/>
+          </a:xfrm>
+        </p:grpSpPr>
+        <p:sp>
+          <p:nvSpPr>
+            <p:cNvPr id="6" name="Retângulo: Cantos Arredondados 5">
+              <a:extLst>
+                <a:ext uri="{FF2B5EF4-FFF2-40B4-BE49-F238E27FC236}">
+                  <a16:creationId xmlns:a16="http://schemas.microsoft.com/office/drawing/2014/main" id="{5D1B0545-E46C-4D76-E185-852F47E9B952}"/>
+                </a:ext>
+              </a:extLst>
+            </p:cNvPr>
+            <p:cNvSpPr/>
+            <p:nvPr/>
+          </p:nvSpPr>
+          <p:spPr>
+            <a:xfrm rot="16200000">
+              <a:off x="25120721" y="3439552"/>
+              <a:ext cx="1122481" cy="14002071"/>
+            </a:xfrm>
+            <a:prstGeom prst="roundRect">
+              <a:avLst>
+                <a:gd name="adj" fmla="val 24349"/>
+              </a:avLst>
+            </a:prstGeom>
+            <a:gradFill flip="none" rotWithShape="1">
+              <a:gsLst>
+                <a:gs pos="0">
+                  <a:srgbClr val="05324B"/>
+                </a:gs>
+                <a:gs pos="62000">
+                  <a:srgbClr val="032030"/>
+                </a:gs>
+                <a:gs pos="76000">
+                  <a:srgbClr val="032030"/>
+                </a:gs>
+                <a:gs pos="100000">
+                  <a:srgbClr val="032030"/>
+                </a:gs>
+              </a:gsLst>
+              <a:lin ang="2700000" scaled="1"/>
+              <a:tileRect/>
+            </a:gradFill>
+            <a:ln>
+              <a:solidFill>
+                <a:srgbClr val="074365"/>
+              </a:solidFill>
+            </a:ln>
+            <a:effectLst>
+              <a:outerShdw blurRad="50800" dist="38100" dir="3300000" algn="t" rotWithShape="0">
+                <a:schemeClr val="bg1">
+                  <a:alpha val="40000"/>
+                </a:schemeClr>
+              </a:outerShdw>
+            </a:effectLst>
+          </p:spPr>
+          <p:style>
+            <a:lnRef idx="2">
+              <a:schemeClr val="accent1">
+                <a:shade val="50000"/>
+              </a:schemeClr>
+            </a:lnRef>
+            <a:fillRef idx="1">
+              <a:schemeClr val="accent1"/>
+            </a:fillRef>
+            <a:effectRef idx="0">
+              <a:schemeClr val="accent1"/>
+            </a:effectRef>
+            <a:fontRef idx="minor">
+              <a:schemeClr val="lt1"/>
+            </a:fontRef>
+          </p:style>
+          <p:txBody>
+            <a:bodyPr vert="vert" rtlCol="0" anchor="ctr"/>
+            <a:lstStyle/>
+            <a:p>
+              <a:pPr algn="ctr"/>
+              <a:endParaRPr lang="pt-BR" sz="3467" dirty="0">
+                <a:solidFill>
+                  <a:schemeClr val="bg1"/>
+                </a:solidFill>
+                <a:latin typeface="Din"/>
+              </a:endParaRPr>
+            </a:p>
+          </p:txBody>
+        </p:sp>
+        <p:sp>
+          <p:nvSpPr>
+            <p:cNvPr id="3" name="CaixaDeTexto 2">
+              <a:extLst>
+                <a:ext uri="{FF2B5EF4-FFF2-40B4-BE49-F238E27FC236}">
+                  <a16:creationId xmlns:a16="http://schemas.microsoft.com/office/drawing/2014/main" id="{6BB21F92-799C-7CFC-3B02-FE0E0585FDFA}"/>
+                </a:ext>
+              </a:extLst>
+            </p:cNvPr>
+            <p:cNvSpPr txBox="1"/>
+            <p:nvPr/>
+          </p:nvSpPr>
+          <p:spPr>
+            <a:xfrm>
+              <a:off x="18891466" y="10005809"/>
+              <a:ext cx="13791531" cy="589818"/>
+            </a:xfrm>
+            <a:prstGeom prst="rect">
+              <a:avLst/>
+            </a:prstGeom>
+            <a:noFill/>
+          </p:spPr>
+          <p:txBody>
+            <a:bodyPr wrap="square" rtlCol="0">
+              <a:spAutoFit/>
+            </a:bodyPr>
+            <a:lstStyle/>
+            <a:p>
+              <a:pPr algn="ctr"/>
+              <a:r>
+                <a:rPr lang="pt-BR" sz="2800" b="1" dirty="0">
+                  <a:solidFill>
+                    <a:schemeClr val="bg1"/>
+                  </a:solidFill>
+                  <a:latin typeface="Din"/>
+                </a:rPr>
+                <a:t>Sales Insights – Visão Executiva</a:t>
+              </a:r>
+            </a:p>
+          </p:txBody>
+        </p:sp>
+        <p:sp>
+          <p:nvSpPr>
+            <p:cNvPr id="8" name="CaixaDeTexto 7">
+              <a:extLst>
+                <a:ext uri="{FF2B5EF4-FFF2-40B4-BE49-F238E27FC236}">
+                  <a16:creationId xmlns:a16="http://schemas.microsoft.com/office/drawing/2014/main" id="{7598B92C-FD88-C6BE-A4A0-3620EF395904}"/>
+                </a:ext>
+              </a:extLst>
+            </p:cNvPr>
+            <p:cNvSpPr txBox="1"/>
+            <p:nvPr/>
+          </p:nvSpPr>
+          <p:spPr>
+            <a:xfrm>
+              <a:off x="18891466" y="10581735"/>
+              <a:ext cx="13791531" cy="346952"/>
+            </a:xfrm>
+            <a:prstGeom prst="rect">
+              <a:avLst/>
+            </a:prstGeom>
+            <a:noFill/>
+          </p:spPr>
+          <p:txBody>
+            <a:bodyPr wrap="square" rtlCol="0">
+              <a:spAutoFit/>
+            </a:bodyPr>
+            <a:lstStyle/>
+            <a:p>
+              <a:pPr algn="ctr"/>
+              <a:r>
+                <a:rPr lang="pt-BR" sz="1400" dirty="0">
+                  <a:solidFill>
+                    <a:schemeClr val="bg2">
+                      <a:lumMod val="90000"/>
+                    </a:schemeClr>
+                  </a:solidFill>
+                  <a:latin typeface="Din"/>
+                </a:rPr>
+                <a:t>Bimbo Brasil</a:t>
+              </a:r>
+              <a:r>
+                <a:rPr lang="pt-BR" sz="1400" b="0" i="0" dirty="0">
+                  <a:solidFill>
+                    <a:schemeClr val="bg2">
+                      <a:lumMod val="90000"/>
+                    </a:schemeClr>
+                  </a:solidFill>
+                  <a:effectLst/>
+                  <a:latin typeface="Segoe UI" panose="020B0502040204020203" pitchFamily="34" charset="0"/>
+                </a:rPr>
+                <a:t> · Controladoria DNA</a:t>
+              </a:r>
+              <a:endParaRPr lang="pt-BR" sz="1400" dirty="0">
+                <a:solidFill>
+                  <a:schemeClr val="bg2">
+                    <a:lumMod val="90000"/>
+                  </a:schemeClr>
+                </a:solidFill>
+                <a:latin typeface="Din"/>
+              </a:endParaRPr>
+            </a:p>
+          </p:txBody>
+        </p:sp>
+      </p:grpSp>
+      <p:sp>
+        <p:nvSpPr>
+          <p:cNvPr id="27" name="Retângulo: Cantos Arredondados 26">
+            <a:extLst>
+              <a:ext uri="{FF2B5EF4-FFF2-40B4-BE49-F238E27FC236}">
+                <a16:creationId xmlns:a16="http://schemas.microsoft.com/office/drawing/2014/main" id="{6E09BF12-3B07-678F-BD0E-5C95075CC238}"/>
+              </a:ext>
+            </a:extLst>
+          </p:cNvPr>
+          <p:cNvSpPr/>
+          <p:nvPr/>
+        </p:nvSpPr>
+        <p:spPr>
+          <a:xfrm>
+            <a:off x="26218798" y="11056799"/>
+            <a:ext cx="7387446" cy="3037120"/>
+          </a:xfrm>
+          <a:prstGeom prst="roundRect">
+            <a:avLst>
+              <a:gd name="adj" fmla="val 5412"/>
+            </a:avLst>
+          </a:prstGeom>
+          <a:solidFill>
+            <a:schemeClr val="bg1"/>
+          </a:solidFill>
+          <a:ln>
+            <a:noFill/>
+          </a:ln>
+          <a:effectLst>
+            <a:outerShdw blurRad="50800" dist="38100" dir="5400000" algn="t" rotWithShape="0">
+              <a:srgbClr val="05324B">
+                <a:alpha val="40000"/>
+              </a:srgbClr>
+            </a:outerShdw>
+          </a:effectLst>
+        </p:spPr>
+        <p:style>
+          <a:lnRef idx="2">
+            <a:schemeClr val="accent1">
+              <a:shade val="50000"/>
+            </a:schemeClr>
+          </a:lnRef>
+          <a:fillRef idx="1">
+            <a:schemeClr val="accent1"/>
+          </a:fillRef>
+          <a:effectRef idx="0">
+            <a:schemeClr val="accent1"/>
+          </a:effectRef>
+          <a:fontRef idx="minor">
+            <a:schemeClr val="lt1"/>
+          </a:fontRef>
+        </p:style>
+        <p:txBody>
+          <a:bodyPr rtlCol="0" anchor="ctr"/>
+          <a:lstStyle/>
+          <a:p>
+            <a:pPr algn="ctr"/>
+            <a:endParaRPr lang="pt-BR" sz="2400" dirty="0">
+              <a:solidFill>
+                <a:prstClr val="white"/>
+              </a:solidFill>
+              <a:latin typeface="Calibri" panose="020F0502020204030204"/>
+            </a:endParaRPr>
+          </a:p>
+        </p:txBody>
+      </p:sp>
+      <p:pic>
+        <p:nvPicPr>
+          <p:cNvPr id="66" name="Imagem 65" descr="Ícone&#10;&#10;O conteúdo gerado por IA pode estar incorreto.">
+            <a:extLst>
+              <a:ext uri="{FF2B5EF4-FFF2-40B4-BE49-F238E27FC236}">
+                <a16:creationId xmlns:a16="http://schemas.microsoft.com/office/drawing/2014/main" id="{CB381AAB-8552-7FB7-A48E-390A782E900F}"/>
+              </a:ext>
+            </a:extLst>
+          </p:cNvPr>
+          <p:cNvPicPr>
+            <a:picLocks noChangeAspect="1"/>
+          </p:cNvPicPr>
+          <p:nvPr/>
+        </p:nvPicPr>
+        <p:blipFill>
+          <a:blip r:embed="rId2">
+            <a:duotone>
+              <a:prstClr val="black"/>
+              <a:schemeClr val="tx2">
+                <a:tint val="45000"/>
+                <a:satMod val="400000"/>
+              </a:schemeClr>
+            </a:duotone>
+            <a:extLst>
+              <a:ext uri="{28A0092B-C50C-407E-A947-70E740481C1C}">
+                <a14:useLocalDpi xmlns:a14="http://schemas.microsoft.com/office/drawing/2010/main" val="0"/>
+              </a:ext>
+            </a:extLst>
+          </a:blip>
+          <a:stretch>
+            <a:fillRect/>
+          </a:stretch>
+        </p:blipFill>
+        <p:spPr>
+          <a:xfrm>
+            <a:off x="17820139" y="13678050"/>
+            <a:ext cx="532661" cy="532661"/>
+          </a:xfrm>
+          <a:prstGeom prst="rect">
+            <a:avLst/>
+          </a:prstGeom>
+        </p:spPr>
+      </p:pic>
+      <p:pic>
+        <p:nvPicPr>
+          <p:cNvPr id="67" name="Imagem 66" descr="Ícone&#10;&#10;O conteúdo gerado por IA pode estar incorreto.">
+            <a:extLst>
+              <a:ext uri="{FF2B5EF4-FFF2-40B4-BE49-F238E27FC236}">
+                <a16:creationId xmlns:a16="http://schemas.microsoft.com/office/drawing/2014/main" id="{0F9ABD0C-BD0F-D960-4787-953D9EB8A160}"/>
+              </a:ext>
+            </a:extLst>
+          </p:cNvPr>
+          <p:cNvPicPr>
+            <a:picLocks noChangeAspect="1"/>
+          </p:cNvPicPr>
+          <p:nvPr/>
+        </p:nvPicPr>
+        <p:blipFill>
+          <a:blip r:embed="rId3">
+            <a:extLst>
+              <a:ext uri="{28A0092B-C50C-407E-A947-70E740481C1C}">
+                <a14:useLocalDpi xmlns:a14="http://schemas.microsoft.com/office/drawing/2010/main" val="0"/>
+              </a:ext>
+            </a:extLst>
+          </a:blip>
+          <a:stretch>
+            <a:fillRect/>
+          </a:stretch>
+        </p:blipFill>
+        <p:spPr>
+          <a:xfrm>
+            <a:off x="17820140" y="11586643"/>
+            <a:ext cx="532661" cy="532661"/>
+          </a:xfrm>
+          <a:prstGeom prst="rect">
+            <a:avLst/>
+          </a:prstGeom>
+          <a:effectLst>
+            <a:glow rad="63500">
+              <a:schemeClr val="accent1">
+                <a:satMod val="175000"/>
+                <a:alpha val="40000"/>
+              </a:schemeClr>
+            </a:glow>
+          </a:effectLst>
+        </p:spPr>
+      </p:pic>
+      <p:pic>
+        <p:nvPicPr>
+          <p:cNvPr id="68" name="Imagem 67" descr="Ícone&#10;&#10;O conteúdo gerado por IA pode estar incorreto.">
+            <a:extLst>
+              <a:ext uri="{FF2B5EF4-FFF2-40B4-BE49-F238E27FC236}">
+                <a16:creationId xmlns:a16="http://schemas.microsoft.com/office/drawing/2014/main" id="{471D48B9-163C-C64A-26DE-D0FD6C3C176D}"/>
+              </a:ext>
+            </a:extLst>
+          </p:cNvPr>
+          <p:cNvPicPr>
+            <a:picLocks noChangeAspect="1"/>
+          </p:cNvPicPr>
+          <p:nvPr/>
+        </p:nvPicPr>
+        <p:blipFill>
+          <a:blip r:embed="rId4">
+            <a:duotone>
+              <a:prstClr val="black"/>
+              <a:schemeClr val="tx2">
+                <a:tint val="45000"/>
+                <a:satMod val="400000"/>
+              </a:schemeClr>
+            </a:duotone>
+            <a:extLst>
+              <a:ext uri="{28A0092B-C50C-407E-A947-70E740481C1C}">
+                <a14:useLocalDpi xmlns:a14="http://schemas.microsoft.com/office/drawing/2010/main" val="0"/>
+              </a:ext>
+            </a:extLst>
+          </a:blip>
+          <a:stretch>
+            <a:fillRect/>
+          </a:stretch>
+        </p:blipFill>
+        <p:spPr>
+          <a:xfrm>
+            <a:off x="17820140" y="12646861"/>
+            <a:ext cx="532660" cy="532660"/>
+          </a:xfrm>
+          <a:prstGeom prst="rect">
+            <a:avLst/>
+          </a:prstGeom>
+        </p:spPr>
+      </p:pic>
+      <p:sp>
+        <p:nvSpPr>
+          <p:cNvPr id="10" name="Retângulo: Cantos Arredondados 9">
+            <a:extLst>
+              <a:ext uri="{FF2B5EF4-FFF2-40B4-BE49-F238E27FC236}">
+                <a16:creationId xmlns:a16="http://schemas.microsoft.com/office/drawing/2014/main" id="{BBAD60BD-161D-7BA3-D129-B0C630C6E1EA}"/>
+              </a:ext>
+            </a:extLst>
+          </p:cNvPr>
+          <p:cNvSpPr/>
+          <p:nvPr/>
+        </p:nvSpPr>
+        <p:spPr>
+          <a:xfrm>
+            <a:off x="18712533" y="12692151"/>
+            <a:ext cx="7387446" cy="3037120"/>
+          </a:xfrm>
+          <a:prstGeom prst="roundRect">
+            <a:avLst>
+              <a:gd name="adj" fmla="val 5412"/>
+            </a:avLst>
+          </a:prstGeom>
+          <a:solidFill>
+            <a:schemeClr val="bg1"/>
+          </a:solidFill>
+          <a:ln>
+            <a:noFill/>
+          </a:ln>
+          <a:effectLst>
+            <a:outerShdw blurRad="50800" dist="38100" dir="5400000" algn="t" rotWithShape="0">
+              <a:srgbClr val="05324B">
+                <a:alpha val="40000"/>
+              </a:srgbClr>
+            </a:outerShdw>
+          </a:effectLst>
+        </p:spPr>
+        <p:style>
+          <a:lnRef idx="2">
+            <a:schemeClr val="accent1">
+              <a:shade val="50000"/>
+            </a:schemeClr>
+          </a:lnRef>
+          <a:fillRef idx="1">
+            <a:schemeClr val="accent1"/>
+          </a:fillRef>
+          <a:effectRef idx="0">
+            <a:schemeClr val="accent1"/>
+          </a:effectRef>
+          <a:fontRef idx="minor">
+            <a:schemeClr val="lt1"/>
+          </a:fontRef>
+        </p:style>
+        <p:txBody>
+          <a:bodyPr rtlCol="0" anchor="ctr"/>
+          <a:lstStyle/>
+          <a:p>
+            <a:pPr algn="ctr"/>
+            <a:endParaRPr lang="pt-BR" sz="2400" dirty="0">
+              <a:solidFill>
+                <a:prstClr val="white"/>
+              </a:solidFill>
+              <a:latin typeface="Calibri" panose="020F0502020204030204"/>
+            </a:endParaRPr>
+          </a:p>
+        </p:txBody>
+      </p:sp>
+      <p:sp>
+        <p:nvSpPr>
+          <p:cNvPr id="11" name="Retângulo: Cantos Arredondados 10">
+            <a:extLst>
+              <a:ext uri="{FF2B5EF4-FFF2-40B4-BE49-F238E27FC236}">
+                <a16:creationId xmlns:a16="http://schemas.microsoft.com/office/drawing/2014/main" id="{6DD85015-A27E-90C9-5F03-CA4F858F0BFD}"/>
+              </a:ext>
+            </a:extLst>
+          </p:cNvPr>
+          <p:cNvSpPr/>
+          <p:nvPr/>
+        </p:nvSpPr>
+        <p:spPr>
+          <a:xfrm>
+            <a:off x="26218798" y="14210711"/>
+            <a:ext cx="7387446" cy="4704618"/>
+          </a:xfrm>
+          <a:prstGeom prst="roundRect">
+            <a:avLst>
+              <a:gd name="adj" fmla="val 5412"/>
+            </a:avLst>
+          </a:prstGeom>
+          <a:solidFill>
+            <a:schemeClr val="bg1"/>
+          </a:solidFill>
+          <a:ln>
+            <a:noFill/>
+          </a:ln>
+          <a:effectLst>
+            <a:outerShdw blurRad="50800" dist="38100" dir="5400000" algn="t" rotWithShape="0">
+              <a:srgbClr val="05324B">
+                <a:alpha val="40000"/>
+              </a:srgbClr>
+            </a:outerShdw>
+          </a:effectLst>
+        </p:spPr>
+        <p:style>
+          <a:lnRef idx="2">
+            <a:schemeClr val="accent1">
+              <a:shade val="50000"/>
+            </a:schemeClr>
+          </a:lnRef>
+          <a:fillRef idx="1">
+            <a:schemeClr val="accent1"/>
+          </a:fillRef>
+          <a:effectRef idx="0">
+            <a:schemeClr val="accent1"/>
+          </a:effectRef>
+          <a:fontRef idx="minor">
+            <a:schemeClr val="lt1"/>
+          </a:fontRef>
+        </p:style>
+        <p:txBody>
+          <a:bodyPr rtlCol="0" anchor="ctr"/>
+          <a:lstStyle/>
+          <a:p>
+            <a:pPr algn="ctr"/>
+            <a:endParaRPr lang="pt-BR" sz="2400" dirty="0">
+              <a:solidFill>
+                <a:prstClr val="white"/>
+              </a:solidFill>
+              <a:latin typeface="Calibri" panose="020F0502020204030204"/>
+            </a:endParaRPr>
+          </a:p>
+        </p:txBody>
+      </p:sp>
+      <p:sp>
+        <p:nvSpPr>
+          <p:cNvPr id="13" name="Retângulo: Cantos Arredondados 12">
+            <a:extLst>
+              <a:ext uri="{FF2B5EF4-FFF2-40B4-BE49-F238E27FC236}">
+                <a16:creationId xmlns:a16="http://schemas.microsoft.com/office/drawing/2014/main" id="{9614608D-5A80-F06D-D026-FE9692B66E79}"/>
+              </a:ext>
+            </a:extLst>
+          </p:cNvPr>
+          <p:cNvSpPr/>
+          <p:nvPr/>
+        </p:nvSpPr>
+        <p:spPr>
+          <a:xfrm>
+            <a:off x="18709573" y="15841810"/>
+            <a:ext cx="7387446" cy="3037120"/>
+          </a:xfrm>
+          <a:prstGeom prst="roundRect">
+            <a:avLst>
+              <a:gd name="adj" fmla="val 5412"/>
+            </a:avLst>
+          </a:prstGeom>
+          <a:solidFill>
+            <a:schemeClr val="bg1"/>
+          </a:solidFill>
+          <a:ln>
+            <a:noFill/>
+          </a:ln>
+          <a:effectLst>
+            <a:outerShdw blurRad="50800" dist="38100" dir="5400000" algn="t" rotWithShape="0">
+              <a:srgbClr val="05324B">
+                <a:alpha val="40000"/>
+              </a:srgbClr>
+            </a:outerShdw>
+          </a:effectLst>
+        </p:spPr>
+        <p:style>
+          <a:lnRef idx="2">
+            <a:schemeClr val="accent1">
+              <a:shade val="50000"/>
+            </a:schemeClr>
+          </a:lnRef>
+          <a:fillRef idx="1">
+            <a:schemeClr val="accent1"/>
+          </a:fillRef>
+          <a:effectRef idx="0">
+            <a:schemeClr val="accent1"/>
+          </a:effectRef>
+          <a:fontRef idx="minor">
+            <a:schemeClr val="lt1"/>
+          </a:fontRef>
+        </p:style>
+        <p:txBody>
+          <a:bodyPr rtlCol="0" anchor="ctr"/>
+          <a:lstStyle/>
+          <a:p>
+            <a:pPr algn="ctr"/>
+            <a:endParaRPr lang="pt-BR" sz="2400" dirty="0">
+              <a:solidFill>
+                <a:prstClr val="white"/>
+              </a:solidFill>
+              <a:latin typeface="Calibri" panose="020F0502020204030204"/>
+            </a:endParaRPr>
+          </a:p>
+        </p:txBody>
+      </p:sp>
+      <p:pic>
+        <p:nvPicPr>
+          <p:cNvPr id="21" name="Imagem 20" descr="Ícone&#10;&#10;O conteúdo gerado por IA pode estar incorreto.">
+            <a:extLst>
+              <a:ext uri="{FF2B5EF4-FFF2-40B4-BE49-F238E27FC236}">
+                <a16:creationId xmlns:a16="http://schemas.microsoft.com/office/drawing/2014/main" id="{8C5C0B3E-5D3D-C23B-388D-B9E3AE4CC77C}"/>
+              </a:ext>
+            </a:extLst>
+          </p:cNvPr>
+          <p:cNvPicPr>
+            <a:picLocks noChangeAspect="1"/>
+          </p:cNvPicPr>
+          <p:nvPr/>
+        </p:nvPicPr>
+        <p:blipFill>
+          <a:blip r:embed="rId5">
+            <a:duotone>
+              <a:prstClr val="black"/>
+              <a:schemeClr val="tx2">
+                <a:tint val="45000"/>
+                <a:satMod val="400000"/>
+              </a:schemeClr>
+            </a:duotone>
+            <a:extLst>
+              <a:ext uri="{28A0092B-C50C-407E-A947-70E740481C1C}">
+                <a14:useLocalDpi xmlns:a14="http://schemas.microsoft.com/office/drawing/2010/main" val="0"/>
+              </a:ext>
+            </a:extLst>
+          </a:blip>
+          <a:stretch>
+            <a:fillRect/>
+          </a:stretch>
+        </p:blipFill>
+        <p:spPr>
+          <a:xfrm>
+            <a:off x="32714027" y="10066769"/>
+            <a:ext cx="713039" cy="713039"/>
+          </a:xfrm>
+          <a:prstGeom prst="rect">
+            <a:avLst/>
+          </a:prstGeom>
+        </p:spPr>
+      </p:pic>
+      <p:sp>
+        <p:nvSpPr>
+          <p:cNvPr id="2" name="Retângulo: Cantos Arredondados 1">
+            <a:extLst>
+              <a:ext uri="{FF2B5EF4-FFF2-40B4-BE49-F238E27FC236}">
+                <a16:creationId xmlns:a16="http://schemas.microsoft.com/office/drawing/2014/main" id="{59D9796C-26DA-572B-9F35-9683714ACBCF}"/>
+              </a:ext>
+            </a:extLst>
+          </p:cNvPr>
+          <p:cNvSpPr/>
+          <p:nvPr/>
+        </p:nvSpPr>
+        <p:spPr>
+          <a:xfrm>
+            <a:off x="23721019" y="11068944"/>
+            <a:ext cx="2376000" cy="1519713"/>
+          </a:xfrm>
+          <a:prstGeom prst="roundRect">
+            <a:avLst/>
+          </a:prstGeom>
+          <a:solidFill>
+            <a:schemeClr val="bg1"/>
+          </a:solidFill>
+          <a:ln>
+            <a:noFill/>
+          </a:ln>
+          <a:effectLst>
+            <a:outerShdw blurRad="50800" dist="38100" dir="5400000" algn="t" rotWithShape="0">
+              <a:srgbClr val="05324B">
+                <a:alpha val="40000"/>
+              </a:srgbClr>
+            </a:outerShdw>
+          </a:effectLst>
+        </p:spPr>
+        <p:style>
+          <a:lnRef idx="2">
+            <a:schemeClr val="accent1">
+              <a:shade val="50000"/>
+            </a:schemeClr>
+          </a:lnRef>
+          <a:fillRef idx="1">
+            <a:schemeClr val="accent1"/>
+          </a:fillRef>
+          <a:effectRef idx="0">
+            <a:schemeClr val="accent1"/>
+          </a:effectRef>
+          <a:fontRef idx="minor">
+            <a:schemeClr val="lt1"/>
+          </a:fontRef>
+        </p:style>
+        <p:txBody>
+          <a:bodyPr rtlCol="0" anchor="ctr"/>
+          <a:lstStyle/>
+          <a:p>
+            <a:pPr algn="ctr"/>
+            <a:endParaRPr lang="pt-BR" sz="2400">
+              <a:solidFill>
+                <a:prstClr val="white"/>
+              </a:solidFill>
+              <a:latin typeface="Calibri" panose="020F0502020204030204"/>
+            </a:endParaRPr>
+          </a:p>
+        </p:txBody>
+      </p:sp>
+      <p:sp>
+        <p:nvSpPr>
+          <p:cNvPr id="4" name="Retângulo: Cantos Arredondados 3">
+            <a:extLst>
+              <a:ext uri="{FF2B5EF4-FFF2-40B4-BE49-F238E27FC236}">
+                <a16:creationId xmlns:a16="http://schemas.microsoft.com/office/drawing/2014/main" id="{50A63148-46F2-1B39-4E5B-49E6AED36A59}"/>
+              </a:ext>
+            </a:extLst>
+          </p:cNvPr>
+          <p:cNvSpPr/>
+          <p:nvPr/>
+        </p:nvSpPr>
+        <p:spPr>
+          <a:xfrm>
+            <a:off x="21215296" y="11081482"/>
+            <a:ext cx="2376000" cy="1519713"/>
+          </a:xfrm>
+          <a:prstGeom prst="roundRect">
+            <a:avLst/>
+          </a:prstGeom>
+          <a:solidFill>
+            <a:schemeClr val="bg1"/>
+          </a:solidFill>
+          <a:ln>
+            <a:noFill/>
+          </a:ln>
+          <a:effectLst>
+            <a:outerShdw blurRad="50800" dist="38100" dir="5400000" algn="t" rotWithShape="0">
+              <a:srgbClr val="05324B">
+                <a:alpha val="40000"/>
+              </a:srgbClr>
+            </a:outerShdw>
+          </a:effectLst>
+        </p:spPr>
+        <p:style>
+          <a:lnRef idx="2">
+            <a:schemeClr val="accent1">
+              <a:shade val="50000"/>
+            </a:schemeClr>
+          </a:lnRef>
+          <a:fillRef idx="1">
+            <a:schemeClr val="accent1"/>
+          </a:fillRef>
+          <a:effectRef idx="0">
+            <a:schemeClr val="accent1"/>
+          </a:effectRef>
+          <a:fontRef idx="minor">
+            <a:schemeClr val="lt1"/>
+          </a:fontRef>
+        </p:style>
+        <p:txBody>
+          <a:bodyPr rtlCol="0" anchor="ctr"/>
+          <a:lstStyle/>
+          <a:p>
+            <a:pPr algn="ctr"/>
+            <a:endParaRPr lang="pt-BR" sz="2400">
+              <a:solidFill>
+                <a:prstClr val="white"/>
+              </a:solidFill>
+              <a:latin typeface="Calibri" panose="020F0502020204030204"/>
+            </a:endParaRPr>
+          </a:p>
+        </p:txBody>
+      </p:sp>
+      <p:sp>
+        <p:nvSpPr>
+          <p:cNvPr id="5" name="Retângulo: Cantos Arredondados 4">
+            <a:extLst>
+              <a:ext uri="{FF2B5EF4-FFF2-40B4-BE49-F238E27FC236}">
+                <a16:creationId xmlns:a16="http://schemas.microsoft.com/office/drawing/2014/main" id="{6E1761A0-E542-5D0A-765B-B18202975CB0}"/>
+              </a:ext>
+            </a:extLst>
+          </p:cNvPr>
+          <p:cNvSpPr/>
+          <p:nvPr/>
+        </p:nvSpPr>
+        <p:spPr>
+          <a:xfrm>
+            <a:off x="18709573" y="11068944"/>
+            <a:ext cx="2376000" cy="1519713"/>
+          </a:xfrm>
+          <a:prstGeom prst="roundRect">
+            <a:avLst/>
+          </a:prstGeom>
+          <a:solidFill>
+            <a:schemeClr val="bg1"/>
+          </a:solidFill>
+          <a:ln>
+            <a:noFill/>
+          </a:ln>
+          <a:effectLst>
+            <a:outerShdw blurRad="50800" dist="38100" dir="5400000" algn="t" rotWithShape="0">
+              <a:srgbClr val="05324B">
+                <a:alpha val="40000"/>
+              </a:srgbClr>
+            </a:outerShdw>
+          </a:effectLst>
+        </p:spPr>
+        <p:style>
+          <a:lnRef idx="2">
+            <a:schemeClr val="accent1">
+              <a:shade val="50000"/>
+            </a:schemeClr>
+          </a:lnRef>
+          <a:fillRef idx="1">
+            <a:schemeClr val="accent1"/>
+          </a:fillRef>
+          <a:effectRef idx="0">
+            <a:schemeClr val="accent1"/>
+          </a:effectRef>
+          <a:fontRef idx="minor">
+            <a:schemeClr val="lt1"/>
+          </a:fontRef>
+        </p:style>
+        <p:txBody>
+          <a:bodyPr rtlCol="0" anchor="ctr"/>
+          <a:lstStyle/>
+          <a:p>
+            <a:pPr algn="ctr"/>
+            <a:endParaRPr lang="pt-BR" sz="2400">
+              <a:solidFill>
+                <a:prstClr val="white"/>
+              </a:solidFill>
+              <a:latin typeface="Calibri" panose="020F0502020204030204"/>
+            </a:endParaRPr>
+          </a:p>
+        </p:txBody>
+      </p:sp>
+    </p:spTree>
+    <p:extLst>
+      <p:ext uri="{BB962C8B-B14F-4D97-AF65-F5344CB8AC3E}">
+        <p14:creationId xmlns:p14="http://schemas.microsoft.com/office/powerpoint/2010/main" val="2065249913"/>
+      </p:ext>
+    </p:extLst>
+  </p:cSld>
+  <p:clrMapOvr>
+    <a:masterClrMapping/>
+  </p:clrMapOvr>
+</p:sld>
+</file>
+
+<file path=ppt/slides/slide3.xml><?xml version="1.0" encoding="utf-8"?>
 <p:sld xmlns:a="http://schemas.openxmlformats.org/drawingml/2006/main" xmlns:r="http://schemas.openxmlformats.org/officeDocument/2006/relationships" xmlns:p="http://schemas.openxmlformats.org/presentationml/2006/main">
   <p:cSld>
     <p:spTree>
@@ -4645,7 +5854,7 @@
         </p:nvSpPr>
         <p:spPr>
           <a:xfrm>
-            <a:off x="18698354" y="11081482"/>
+            <a:off x="26229453" y="11081482"/>
             <a:ext cx="7387446" cy="7890750"/>
           </a:xfrm>
           <a:prstGeom prst="roundRect">
@@ -4841,7 +6050,7 @@
         </p:nvSpPr>
         <p:spPr>
           <a:xfrm>
-            <a:off x="26215273" y="15935112"/>
+            <a:off x="18709573" y="15935112"/>
             <a:ext cx="7387446" cy="3037120"/>
           </a:xfrm>
           <a:prstGeom prst="roundRect">
@@ -4907,7 +6116,7 @@
         </p:nvSpPr>
         <p:spPr>
           <a:xfrm>
-            <a:off x="26215274" y="12748980"/>
+            <a:off x="18709574" y="12748980"/>
             <a:ext cx="7387446" cy="3037120"/>
           </a:xfrm>
           <a:prstGeom prst="roundRect">
@@ -5016,7 +6225,7 @@
         </p:nvSpPr>
         <p:spPr>
           <a:xfrm>
-            <a:off x="31226719" y="11068944"/>
+            <a:off x="23721019" y="11068944"/>
             <a:ext cx="2376000" cy="1519713"/>
           </a:xfrm>
           <a:prstGeom prst="roundRect">
@@ -5080,7 +6289,7 @@
         </p:nvSpPr>
         <p:spPr>
           <a:xfrm>
-            <a:off x="28720996" y="11081482"/>
+            <a:off x="21215296" y="11081482"/>
             <a:ext cx="2376000" cy="1519713"/>
           </a:xfrm>
           <a:prstGeom prst="roundRect">
@@ -5144,7 +6353,7 @@
         </p:nvSpPr>
         <p:spPr>
           <a:xfrm>
-            <a:off x="26215273" y="11068944"/>
+            <a:off x="18709573" y="11068944"/>
             <a:ext cx="2376000" cy="1519713"/>
           </a:xfrm>
           <a:prstGeom prst="roundRect">
@@ -5207,7 +6416,7 @@
 </p:sld>
 </file>
 
-<file path=ppt/slides/slide3.xml><?xml version="1.0" encoding="utf-8"?>
+<file path=ppt/slides/slide4.xml><?xml version="1.0" encoding="utf-8"?>
 <p:sld xmlns:a="http://schemas.openxmlformats.org/drawingml/2006/main" xmlns:r="http://schemas.openxmlformats.org/officeDocument/2006/relationships" xmlns:p="http://schemas.openxmlformats.org/presentationml/2006/main">
   <p:cSld>
     <p:spTree>
@@ -6242,7 +7451,7 @@
 </p:sld>
 </file>
 
-<file path=ppt/slides/slide4.xml><?xml version="1.0" encoding="utf-8"?>
+<file path=ppt/slides/slide5.xml><?xml version="1.0" encoding="utf-8"?>
 <p:sld xmlns:a="http://schemas.openxmlformats.org/drawingml/2006/main" xmlns:r="http://schemas.openxmlformats.org/officeDocument/2006/relationships" xmlns:p="http://schemas.openxmlformats.org/presentationml/2006/main">
   <p:cSld>
     <p:spTree>
@@ -6418,7 +7627,7 @@
 </p:sld>
 </file>
 
-<file path=ppt/slides/slide5.xml><?xml version="1.0" encoding="utf-8"?>
+<file path=ppt/slides/slide6.xml><?xml version="1.0" encoding="utf-8"?>
 <p:sld xmlns:a="http://schemas.openxmlformats.org/drawingml/2006/main" xmlns:r="http://schemas.openxmlformats.org/officeDocument/2006/relationships" xmlns:p="http://schemas.openxmlformats.org/presentationml/2006/main">
   <p:cSld>
     <p:spTree>
@@ -6602,7 +7811,7 @@
 </p:sld>
 </file>
 
-<file path=ppt/slides/slide6.xml><?xml version="1.0" encoding="utf-8"?>
+<file path=ppt/slides/slide7.xml><?xml version="1.0" encoding="utf-8"?>
 <p:sld xmlns:a="http://schemas.openxmlformats.org/drawingml/2006/main" xmlns:r="http://schemas.openxmlformats.org/officeDocument/2006/relationships" xmlns:p="http://schemas.openxmlformats.org/presentationml/2006/main">
   <p:cSld>
     <p:spTree>
@@ -6960,7 +8169,7 @@
 </p:sld>
 </file>
 
-<file path=ppt/slides/slide7.xml><?xml version="1.0" encoding="utf-8"?>
+<file path=ppt/slides/slide8.xml><?xml version="1.0" encoding="utf-8"?>
 <p:sld xmlns:a="http://schemas.openxmlformats.org/drawingml/2006/main" xmlns:r="http://schemas.openxmlformats.org/officeDocument/2006/relationships" xmlns:p="http://schemas.openxmlformats.org/presentationml/2006/main">
   <p:cSld>
     <p:spTree>
@@ -7184,7 +8393,7 @@
 </p:sld>
 </file>
 
-<file path=ppt/slides/slide8.xml><?xml version="1.0" encoding="utf-8"?>
+<file path=ppt/slides/slide9.xml><?xml version="1.0" encoding="utf-8"?>
 <p:sld xmlns:a="http://schemas.openxmlformats.org/drawingml/2006/main" xmlns:r="http://schemas.openxmlformats.org/officeDocument/2006/relationships" xmlns:p="http://schemas.openxmlformats.org/presentationml/2006/main">
   <p:cSld>
     <p:spTree>
@@ -7384,197 +8593,6 @@
     <p:extLst>
       <p:ext uri="{BB962C8B-B14F-4D97-AF65-F5344CB8AC3E}">
         <p14:creationId xmlns:p14="http://schemas.microsoft.com/office/powerpoint/2010/main" val="3924949865"/>
-      </p:ext>
-    </p:extLst>
-  </p:cSld>
-  <p:clrMapOvr>
-    <a:masterClrMapping/>
-  </p:clrMapOvr>
-</p:sld>
-</file>
-
-<file path=ppt/slides/slide9.xml><?xml version="1.0" encoding="utf-8"?>
-<p:sld xmlns:a="http://schemas.openxmlformats.org/drawingml/2006/main" xmlns:r="http://schemas.openxmlformats.org/officeDocument/2006/relationships" xmlns:p="http://schemas.openxmlformats.org/presentationml/2006/main">
-  <p:cSld>
-    <p:spTree>
-      <p:nvGrpSpPr>
-        <p:cNvPr id="1" name="">
-          <a:extLst>
-            <a:ext uri="{FF2B5EF4-FFF2-40B4-BE49-F238E27FC236}">
-              <a16:creationId xmlns:a16="http://schemas.microsoft.com/office/drawing/2014/main" id="{36DD52CC-89D5-2710-7D87-2A2E2CFF65E6}"/>
-            </a:ext>
-          </a:extLst>
-        </p:cNvPr>
-        <p:cNvGrpSpPr/>
-        <p:nvPr/>
-      </p:nvGrpSpPr>
-      <p:grpSpPr>
-        <a:xfrm>
-          <a:off x="0" y="0"/>
-          <a:ext cx="0" cy="0"/>
-          <a:chOff x="0" y="0"/>
-          <a:chExt cx="0" cy="0"/>
-        </a:xfrm>
-      </p:grpSpPr>
-      <p:sp>
-        <p:nvSpPr>
-          <p:cNvPr id="7" name="Retângulo: Cantos Arredondados 6">
-            <a:extLst>
-              <a:ext uri="{FF2B5EF4-FFF2-40B4-BE49-F238E27FC236}">
-                <a16:creationId xmlns:a16="http://schemas.microsoft.com/office/drawing/2014/main" id="{CC759720-71A5-1FCB-8BB1-A173F10EDD06}"/>
-              </a:ext>
-            </a:extLst>
-          </p:cNvPr>
-          <p:cNvSpPr/>
-          <p:nvPr/>
-        </p:nvSpPr>
-        <p:spPr>
-          <a:xfrm>
-            <a:off x="17697870" y="11242142"/>
-            <a:ext cx="13889388" cy="7611537"/>
-          </a:xfrm>
-          <a:prstGeom prst="roundRect">
-            <a:avLst>
-              <a:gd name="adj" fmla="val 3334"/>
-            </a:avLst>
-          </a:prstGeom>
-          <a:gradFill flip="none" rotWithShape="1">
-            <a:gsLst>
-              <a:gs pos="0">
-                <a:srgbClr val="05324B"/>
-              </a:gs>
-              <a:gs pos="62000">
-                <a:srgbClr val="032030"/>
-              </a:gs>
-              <a:gs pos="76000">
-                <a:srgbClr val="032030"/>
-              </a:gs>
-              <a:gs pos="100000">
-                <a:srgbClr val="032030"/>
-              </a:gs>
-            </a:gsLst>
-            <a:path path="circle">
-              <a:fillToRect l="50000" t="50000" r="50000" b="50000"/>
-            </a:path>
-            <a:tileRect/>
-          </a:gradFill>
-          <a:ln>
-            <a:noFill/>
-          </a:ln>
-        </p:spPr>
-        <p:style>
-          <a:lnRef idx="2">
-            <a:schemeClr val="accent1">
-              <a:shade val="50000"/>
-            </a:schemeClr>
-          </a:lnRef>
-          <a:fillRef idx="1">
-            <a:schemeClr val="accent1"/>
-          </a:fillRef>
-          <a:effectRef idx="0">
-            <a:schemeClr val="accent1"/>
-          </a:effectRef>
-          <a:fontRef idx="minor">
-            <a:schemeClr val="lt1"/>
-          </a:fontRef>
-        </p:style>
-        <p:txBody>
-          <a:bodyPr rtlCol="0" anchor="ctr"/>
-          <a:lstStyle/>
-          <a:p>
-            <a:pPr algn="ctr"/>
-            <a:endParaRPr lang="pt-BR" sz="2400"/>
-          </a:p>
-        </p:txBody>
-      </p:sp>
-      <p:sp>
-        <p:nvSpPr>
-          <p:cNvPr id="11" name="Retângulo: Cantos Arredondados 10">
-            <a:extLst>
-              <a:ext uri="{FF2B5EF4-FFF2-40B4-BE49-F238E27FC236}">
-                <a16:creationId xmlns:a16="http://schemas.microsoft.com/office/drawing/2014/main" id="{7FD3E36B-204D-5D77-C84C-6FCBBB86874D}"/>
-              </a:ext>
-            </a:extLst>
-          </p:cNvPr>
-          <p:cNvSpPr/>
-          <p:nvPr/>
-        </p:nvSpPr>
-        <p:spPr>
-          <a:xfrm>
-            <a:off x="18084800" y="11635685"/>
-            <a:ext cx="13068300" cy="1213647"/>
-          </a:xfrm>
-          <a:prstGeom prst="roundRect">
-            <a:avLst>
-              <a:gd name="adj" fmla="val 12781"/>
-            </a:avLst>
-          </a:prstGeom>
-          <a:gradFill flip="none" rotWithShape="1">
-            <a:gsLst>
-              <a:gs pos="0">
-                <a:srgbClr val="365160"/>
-              </a:gs>
-              <a:gs pos="62000">
-                <a:srgbClr val="032030"/>
-              </a:gs>
-              <a:gs pos="76000">
-                <a:srgbClr val="032030"/>
-              </a:gs>
-              <a:gs pos="100000">
-                <a:srgbClr val="032030"/>
-              </a:gs>
-            </a:gsLst>
-            <a:lin ang="2700000" scaled="1"/>
-            <a:tileRect/>
-          </a:gradFill>
-          <a:ln>
-            <a:noFill/>
-          </a:ln>
-          <a:effectLst>
-            <a:outerShdw blurRad="50800" dist="38100" dir="3300000" algn="t" rotWithShape="0">
-              <a:schemeClr val="bg1">
-                <a:alpha val="40000"/>
-              </a:schemeClr>
-            </a:outerShdw>
-          </a:effectLst>
-        </p:spPr>
-        <p:style>
-          <a:lnRef idx="2">
-            <a:schemeClr val="accent1">
-              <a:shade val="50000"/>
-            </a:schemeClr>
-          </a:lnRef>
-          <a:fillRef idx="1">
-            <a:schemeClr val="accent1"/>
-          </a:fillRef>
-          <a:effectRef idx="0">
-            <a:schemeClr val="accent1"/>
-          </a:effectRef>
-          <a:fontRef idx="minor">
-            <a:schemeClr val="lt1"/>
-          </a:fontRef>
-        </p:style>
-        <p:txBody>
-          <a:bodyPr rtlCol="0" anchor="ctr"/>
-          <a:lstStyle/>
-          <a:p>
-            <a:pPr algn="ctr"/>
-            <a:r>
-              <a:rPr lang="pt-BR" sz="4400" b="1" dirty="0">
-                <a:solidFill>
-                  <a:schemeClr val="bg1"/>
-                </a:solidFill>
-                <a:latin typeface="Din"/>
-              </a:rPr>
-              <a:t>Unidades Vendidas por Mês</a:t>
-            </a:r>
-          </a:p>
-        </p:txBody>
-      </p:sp>
-    </p:spTree>
-    <p:extLst>
-      <p:ext uri="{BB962C8B-B14F-4D97-AF65-F5344CB8AC3E}">
-        <p14:creationId xmlns:p14="http://schemas.microsoft.com/office/powerpoint/2010/main" val="3329092916"/>
       </p:ext>
     </p:extLst>
   </p:cSld>
@@ -7846,29 +8864,6 @@
 </file>
 
 <file path=customXml/item1.xml><?xml version="1.0" encoding="utf-8"?>
-<p:properties xmlns:p="http://schemas.microsoft.com/office/2006/metadata/properties" xmlns:xsi="http://www.w3.org/2001/XMLSchema-instance" xmlns:pc="http://schemas.microsoft.com/office/infopath/2007/PartnerControls">
-  <documentManagement>
-    <_ip_UnifiedCompliancePolicyUIAction xmlns="http://schemas.microsoft.com/sharepoint/v3" xsi:nil="true"/>
-    <lcf76f155ced4ddcb4097134ff3c332f xmlns="996f600e-0733-4526-a0fb-b18e680a05e7">
-      <Terms xmlns="http://schemas.microsoft.com/office/infopath/2007/PartnerControls"/>
-    </lcf76f155ced4ddcb4097134ff3c332f>
-    <TaxCatchAll xmlns="137de72a-d4ba-42bd-86fe-71b4bed90a39" xsi:nil="true"/>
-    <_ip_UnifiedCompliancePolicyProperties xmlns="http://schemas.microsoft.com/sharepoint/v3" xsi:nil="true"/>
-    <_Flow_SignoffStatus xmlns="996f600e-0733-4526-a0fb-b18e680a05e7" xsi:nil="true"/>
-  </documentManagement>
-</p:properties>
-</file>
-
-<file path=customXml/item2.xml><?xml version="1.0" encoding="utf-8"?>
-<?mso-contentType ?>
-<FormTemplates xmlns="http://schemas.microsoft.com/sharepoint/v3/contenttype/forms">
-  <Display>DocumentLibraryForm</Display>
-  <Edit>DocumentLibraryForm</Edit>
-  <New>DocumentLibraryForm</New>
-</FormTemplates>
-</file>
-
-<file path=customXml/item3.xml><?xml version="1.0" encoding="utf-8"?>
 <ct:contentTypeSchema xmlns:ct="http://schemas.microsoft.com/office/2006/metadata/contentType" xmlns:ma="http://schemas.microsoft.com/office/2006/metadata/properties/metaAttributes" ct:_="" ma:_="" ma:contentTypeName="Documento" ma:contentTypeID="0x010100BD8796E1EBEF0447B8A50267FB38BA07" ma:contentTypeVersion="21" ma:contentTypeDescription="Crie um novo documento." ma:contentTypeScope="" ma:versionID="51b69d7bf1e80634fb6243a48f7b967a">
   <xsd:schema xmlns:xsd="http://www.w3.org/2001/XMLSchema" xmlns:xs="http://www.w3.org/2001/XMLSchema" xmlns:p="http://schemas.microsoft.com/office/2006/metadata/properties" xmlns:ns1="http://schemas.microsoft.com/sharepoint/v3" xmlns:ns2="137de72a-d4ba-42bd-86fe-71b4bed90a39" xmlns:ns3="996f600e-0733-4526-a0fb-b18e680a05e7" targetNamespace="http://schemas.microsoft.com/office/2006/metadata/properties" ma:root="true" ma:fieldsID="ff2cafffd62144788c92268155a1b106" ns1:_="" ns2:_="" ns3:_="">
     <xsd:import namespace="http://schemas.microsoft.com/sharepoint/v3"/>
@@ -8146,33 +9141,30 @@
 </ct:contentTypeSchema>
 </file>
 
-<file path=customXml/itemProps1.xml><?xml version="1.0" encoding="utf-8"?>
-<ds:datastoreItem xmlns:ds="http://schemas.openxmlformats.org/officeDocument/2006/customXml" ds:itemID="{BCFDE38A-F306-4C4A-AFC1-208A8755E640}">
-  <ds:schemaRefs>
-    <ds:schemaRef ds:uri="http://purl.org/dc/elements/1.1/"/>
-    <ds:schemaRef ds:uri="http://schemas.microsoft.com/sharepoint/v3"/>
-    <ds:schemaRef ds:uri="http://schemas.openxmlformats.org/package/2006/metadata/core-properties"/>
-    <ds:schemaRef ds:uri="http://purl.org/dc/terms/"/>
-    <ds:schemaRef ds:uri="http://schemas.microsoft.com/office/infopath/2007/PartnerControls"/>
-    <ds:schemaRef ds:uri="http://schemas.microsoft.com/office/2006/documentManagement/types"/>
-    <ds:schemaRef ds:uri="996f600e-0733-4526-a0fb-b18e680a05e7"/>
-    <ds:schemaRef ds:uri="http://schemas.microsoft.com/office/2006/metadata/properties"/>
-    <ds:schemaRef ds:uri="137de72a-d4ba-42bd-86fe-71b4bed90a39"/>
-    <ds:schemaRef ds:uri="http://www.w3.org/XML/1998/namespace"/>
-    <ds:schemaRef ds:uri="http://purl.org/dc/dcmitype/"/>
-  </ds:schemaRefs>
-</ds:datastoreItem>
+<file path=customXml/item2.xml><?xml version="1.0" encoding="utf-8"?>
+<?mso-contentType ?>
+<FormTemplates xmlns="http://schemas.microsoft.com/sharepoint/v3/contenttype/forms">
+  <Display>DocumentLibraryForm</Display>
+  <Edit>DocumentLibraryForm</Edit>
+  <New>DocumentLibraryForm</New>
+</FormTemplates>
 </file>
 
-<file path=customXml/itemProps2.xml><?xml version="1.0" encoding="utf-8"?>
-<ds:datastoreItem xmlns:ds="http://schemas.openxmlformats.org/officeDocument/2006/customXml" ds:itemID="{AAE51230-9E4E-4FDB-9D86-2789E42C6788}">
-  <ds:schemaRefs>
-    <ds:schemaRef ds:uri="http://schemas.microsoft.com/sharepoint/v3/contenttype/forms"/>
-  </ds:schemaRefs>
-</ds:datastoreItem>
+<file path=customXml/item3.xml><?xml version="1.0" encoding="utf-8"?>
+<p:properties xmlns:p="http://schemas.microsoft.com/office/2006/metadata/properties" xmlns:xsi="http://www.w3.org/2001/XMLSchema-instance" xmlns:pc="http://schemas.microsoft.com/office/infopath/2007/PartnerControls">
+  <documentManagement>
+    <_ip_UnifiedCompliancePolicyUIAction xmlns="http://schemas.microsoft.com/sharepoint/v3" xsi:nil="true"/>
+    <lcf76f155ced4ddcb4097134ff3c332f xmlns="996f600e-0733-4526-a0fb-b18e680a05e7">
+      <Terms xmlns="http://schemas.microsoft.com/office/infopath/2007/PartnerControls"/>
+    </lcf76f155ced4ddcb4097134ff3c332f>
+    <TaxCatchAll xmlns="137de72a-d4ba-42bd-86fe-71b4bed90a39" xsi:nil="true"/>
+    <_ip_UnifiedCompliancePolicyProperties xmlns="http://schemas.microsoft.com/sharepoint/v3" xsi:nil="true"/>
+    <_Flow_SignoffStatus xmlns="996f600e-0733-4526-a0fb-b18e680a05e7" xsi:nil="true"/>
+  </documentManagement>
+</p:properties>
 </file>
 
-<file path=customXml/itemProps3.xml><?xml version="1.0" encoding="utf-8"?>
+<file path=customXml/itemProps1.xml><?xml version="1.0" encoding="utf-8"?>
 <ds:datastoreItem xmlns:ds="http://schemas.openxmlformats.org/officeDocument/2006/customXml" ds:itemID="{56FEFCE5-4A7D-48BD-A3A8-BA9D11A8CFE8}">
   <ds:schemaRefs>
     <ds:schemaRef ds:uri="http://schemas.microsoft.com/office/2006/metadata/contentType"/>
@@ -8190,4 +9182,30 @@
     <ds:schemaRef ds:uri="http://schemas.microsoft.com/internal/obd"/>
   </ds:schemaRefs>
 </ds:datastoreItem>
+</file>
+
+<file path=customXml/itemProps2.xml><?xml version="1.0" encoding="utf-8"?>
+<ds:datastoreItem xmlns:ds="http://schemas.openxmlformats.org/officeDocument/2006/customXml" ds:itemID="{AAE51230-9E4E-4FDB-9D86-2789E42C6788}">
+  <ds:schemaRefs>
+    <ds:schemaRef ds:uri="http://schemas.microsoft.com/sharepoint/v3/contenttype/forms"/>
+  </ds:schemaRefs>
+</ds:datastoreItem>
+</file>
+
+<file path=customXml/itemProps3.xml><?xml version="1.0" encoding="utf-8"?>
+<ds:datastoreItem xmlns:ds="http://schemas.openxmlformats.org/officeDocument/2006/customXml" ds:itemID="{BCFDE38A-F306-4C4A-AFC1-208A8755E640}">
+  <ds:schemaRefs>
+    <ds:schemaRef ds:uri="http://purl.org/dc/elements/1.1/"/>
+    <ds:schemaRef ds:uri="http://schemas.microsoft.com/sharepoint/v3"/>
+    <ds:schemaRef ds:uri="http://schemas.openxmlformats.org/package/2006/metadata/core-properties"/>
+    <ds:schemaRef ds:uri="http://purl.org/dc/terms/"/>
+    <ds:schemaRef ds:uri="http://schemas.microsoft.com/office/infopath/2007/PartnerControls"/>
+    <ds:schemaRef ds:uri="http://schemas.microsoft.com/office/2006/documentManagement/types"/>
+    <ds:schemaRef ds:uri="996f600e-0733-4526-a0fb-b18e680a05e7"/>
+    <ds:schemaRef ds:uri="http://schemas.microsoft.com/office/2006/metadata/properties"/>
+    <ds:schemaRef ds:uri="137de72a-d4ba-42bd-86fe-71b4bed90a39"/>
+    <ds:schemaRef ds:uri="http://www.w3.org/XML/1998/namespace"/>
+    <ds:schemaRef ds:uri="http://purl.org/dc/dcmitype/"/>
+  </ds:schemaRefs>
+</ds:datastoreItem>
 </file>
</xml_diff>